<commit_message>
Case study reads in-site; product-first deck; clickable screenshot; 12-min cron
1. No more GitHub round-trips — the 10 case-study docs are pre-rendered to
   styled HTML (tools/build_docs.py) in the same design system, with prev/next
   nav and a GitHub-compatible slugifier so every cross-link and anchor
   resolves in-site. Hub + README now link to the rendered pages.
2. Product first — both the .pptx and the web deck now open with the product
   (screenshot, then how it works) before the problem/insight argument.
   Renumbered: 01 Product, 02 Problem, 03 Insight.
3. Case-study hub leads with the live product screenshot, clickable → live app.
4. Keep-warm cron 10 → 12 min.

Also moves the deck/doc generators out of scratch into versioned tools/ so
both artifacts are reproducible.

Co-Authored-By: Claude Opus 4.8 (1M context) <noreply@anthropic.com>
</commit_message>
<xml_diff>
--- a/docs/postmeet-pitch.pptx
+++ b/docs/postmeet-pitch.pptx
@@ -6215,7 +6215,7 @@
                 </a:solidFill>
                 <a:latin typeface="Consolas"/>
               </a:rPr>
-              <a:t>   ·   postmeet.onrender.com   ·   github.com/Shubham-33/postmeet</a:t>
+              <a:t>   ·   postmeet.onrender.com   ·   shubham-33.github.io/postmeet/case-study/</a:t>
             </a:r>
           </a:p>
         </p:txBody>
@@ -6366,7 +6366,7 @@
                 </a:solidFill>
                 <a:latin typeface="Consolas"/>
               </a:rPr>
-              <a:t>01 · THE PROBLEM</a:t>
+              <a:t>—  SEE IT WORK</a:t>
             </a:r>
           </a:p>
         </p:txBody>
@@ -6405,27 +6405,95 @@
               </a:spcAft>
             </a:pPr>
             <a:r>
-              <a:rPr sz="3300" b="1">
+              <a:rPr sz="2800" b="1">
                 <a:solidFill>
                   <a:srgbClr val="16181F"/>
                 </a:solidFill>
                 <a:latin typeface="Calibri"/>
               </a:rPr>
-              <a:t>Meetings manufacture commitments. Then the commitments go missing.</a:t>
-            </a:r>
-          </a:p>
-        </p:txBody>
-      </p:sp>
-      <p:sp>
-        <p:nvSpPr>
-          <p:cNvPr id="6" name="TextBox 5"/>
-          <p:cNvSpPr txBox="1"/>
-          <p:nvPr/>
-        </p:nvSpPr>
-        <p:spPr>
-          <a:xfrm>
-            <a:off x="822960" y="2286000"/>
-            <a:ext cx="4023360" cy="1280160"/>
+              <a:t>Paste a transcript → the board writes itself.</a:t>
+            </a:r>
+          </a:p>
+        </p:txBody>
+      </p:sp>
+      <p:pic>
+        <p:nvPicPr>
+          <p:cNvPr id="6" name="Picture 5" descr="postmeet-screenshot.png"/>
+          <p:cNvPicPr>
+            <a:picLocks noChangeAspect="1"/>
+          </p:cNvPicPr>
+          <p:nvPr/>
+        </p:nvPicPr>
+        <p:blipFill>
+          <a:blip r:embed="rId2"/>
+          <a:stretch>
+            <a:fillRect/>
+          </a:stretch>
+        </p:blipFill>
+        <p:spPr>
+          <a:xfrm>
+            <a:off x="3013488" y="1645920"/>
+            <a:ext cx="6164719" cy="4709160"/>
+          </a:xfrm>
+          <a:prstGeom prst="rect">
+            <a:avLst/>
+          </a:prstGeom>
+        </p:spPr>
+      </p:pic>
+      <p:sp>
+        <p:nvSpPr>
+          <p:cNvPr id="7" name="Rectangle 6"/>
+          <p:cNvSpPr/>
+          <p:nvPr/>
+        </p:nvSpPr>
+        <p:spPr>
+          <a:xfrm>
+            <a:off x="3013488" y="1645920"/>
+            <a:ext cx="6164718" cy="4709160"/>
+          </a:xfrm>
+          <a:prstGeom prst="rect">
+            <a:avLst/>
+          </a:prstGeom>
+          <a:noFill/>
+          <a:ln w="12700">
+            <a:solidFill>
+              <a:srgbClr val="DEE1E7"/>
+            </a:solidFill>
+          </a:ln>
+          <a:effectLst/>
+        </p:spPr>
+        <p:style>
+          <a:lnRef idx="1">
+            <a:schemeClr val="accent1"/>
+          </a:lnRef>
+          <a:fillRef idx="3">
+            <a:schemeClr val="accent1"/>
+          </a:fillRef>
+          <a:effectRef idx="2">
+            <a:schemeClr val="accent1"/>
+          </a:effectRef>
+          <a:fontRef idx="minor">
+            <a:schemeClr val="lt1"/>
+          </a:fontRef>
+        </p:style>
+        <p:txBody>
+          <a:bodyPr rtlCol="0" anchor="ctr"/>
+          <a:lstStyle/>
+          <a:p>
+            <a:pPr algn="ctr"/>
+          </a:p>
+        </p:txBody>
+      </p:sp>
+      <p:sp>
+        <p:nvSpPr>
+          <p:cNvPr id="8" name="TextBox 7"/>
+          <p:cNvSpPr txBox="1"/>
+          <p:nvPr/>
+        </p:nvSpPr>
+        <p:spPr>
+          <a:xfrm>
+            <a:off x="822960" y="6419088"/>
+            <a:ext cx="10515600" cy="320040"/>
           </a:xfrm>
           <a:prstGeom prst="rect">
             <a:avLst/>
@@ -6450,373 +6518,13 @@
               </a:spcAft>
             </a:pPr>
             <a:r>
-              <a:rPr sz="6600" b="1">
-                <a:solidFill>
-                  <a:srgbClr val="C2410C"/>
+              <a:rPr sz="1050" b="0">
+                <a:solidFill>
+                  <a:srgbClr val="8B919D"/>
                 </a:solidFill>
                 <a:latin typeface="Calibri"/>
               </a:rPr>
-              <a:t>~70%</a:t>
-            </a:r>
-          </a:p>
-        </p:txBody>
-      </p:sp>
-      <p:sp>
-        <p:nvSpPr>
-          <p:cNvPr id="7" name="TextBox 6"/>
-          <p:cNvSpPr txBox="1"/>
-          <p:nvPr/>
-        </p:nvSpPr>
-        <p:spPr>
-          <a:xfrm>
-            <a:off x="822960" y="3566160"/>
-            <a:ext cx="4480560" cy="1737360"/>
-          </a:xfrm>
-          <a:prstGeom prst="rect">
-            <a:avLst/>
-          </a:prstGeom>
-          <a:noFill/>
-        </p:spPr>
-        <p:txBody>
-          <a:bodyPr wrap="square" anchor="t">
-            <a:spAutoFit/>
-          </a:bodyPr>
-          <a:lstStyle/>
-          <a:p>
-            <a:pPr algn="l">
-              <a:lnSpc>
-                <a:spcPct val="116000"/>
-              </a:lnSpc>
-              <a:spcBef>
-                <a:spcPts val="0"/>
-              </a:spcBef>
-              <a:spcAft>
-                <a:spcPts val="0"/>
-              </a:spcAft>
-            </a:pPr>
-            <a:r>
-              <a:rPr sz="1550" b="0">
-                <a:solidFill>
-                  <a:srgbClr val="5A616E"/>
-                </a:solidFill>
-                <a:latin typeface="Calibri"/>
-              </a:rPr>
-              <a:t>of meeting action items are never completed — they live in someone's notes, a Slack thread, a doc nobody reopens.</a:t>
-            </a:r>
-          </a:p>
-        </p:txBody>
-      </p:sp>
-      <p:sp>
-        <p:nvSpPr>
-          <p:cNvPr id="8" name="TextBox 7"/>
-          <p:cNvSpPr txBox="1"/>
-          <p:nvPr/>
-        </p:nvSpPr>
-        <p:spPr>
-          <a:xfrm>
-            <a:off x="5486400" y="2331720"/>
-            <a:ext cx="914400" cy="365760"/>
-          </a:xfrm>
-          <a:prstGeom prst="rect">
-            <a:avLst/>
-          </a:prstGeom>
-          <a:noFill/>
-        </p:spPr>
-        <p:txBody>
-          <a:bodyPr wrap="square" anchor="t">
-            <a:spAutoFit/>
-          </a:bodyPr>
-          <a:lstStyle/>
-          <a:p>
-            <a:pPr algn="l">
-              <a:lnSpc>
-                <a:spcPct val="106000"/>
-              </a:lnSpc>
-              <a:spcBef>
-                <a:spcPts val="0"/>
-              </a:spcBef>
-              <a:spcAft>
-                <a:spcPts val="0"/>
-              </a:spcAft>
-            </a:pPr>
-            <a:r>
-              <a:rPr sz="1250" b="1">
-                <a:solidFill>
-                  <a:srgbClr val="C2410C"/>
-                </a:solidFill>
-                <a:latin typeface="Consolas"/>
-              </a:rPr>
-              <a:t>who</a:t>
-            </a:r>
-          </a:p>
-        </p:txBody>
-      </p:sp>
-      <p:sp>
-        <p:nvSpPr>
-          <p:cNvPr id="9" name="TextBox 8"/>
-          <p:cNvSpPr txBox="1"/>
-          <p:nvPr/>
-        </p:nvSpPr>
-        <p:spPr>
-          <a:xfrm>
-            <a:off x="6400800" y="2313432"/>
-            <a:ext cx="4937760" cy="1005840"/>
-          </a:xfrm>
-          <a:prstGeom prst="rect">
-            <a:avLst/>
-          </a:prstGeom>
-          <a:noFill/>
-        </p:spPr>
-        <p:txBody>
-          <a:bodyPr wrap="square" anchor="t">
-            <a:spAutoFit/>
-          </a:bodyPr>
-          <a:lstStyle/>
-          <a:p>
-            <a:pPr algn="l">
-              <a:lnSpc>
-                <a:spcPct val="112000"/>
-              </a:lnSpc>
-              <a:spcBef>
-                <a:spcPts val="0"/>
-              </a:spcBef>
-              <a:spcAft>
-                <a:spcPts val="0"/>
-              </a:spcAft>
-            </a:pPr>
-            <a:r>
-              <a:rPr sz="1450" b="0">
-                <a:solidFill>
-                  <a:srgbClr val="5A616E"/>
-                </a:solidFill>
-                <a:latin typeface="Calibri"/>
-              </a:rPr>
-              <a:t>Knowledge workers spend a huge share of the week in meetings — what matters is the follow-through, not the recording.</a:t>
-            </a:r>
-          </a:p>
-        </p:txBody>
-      </p:sp>
-      <p:sp>
-        <p:nvSpPr>
-          <p:cNvPr id="10" name="TextBox 9"/>
-          <p:cNvSpPr txBox="1"/>
-          <p:nvPr/>
-        </p:nvSpPr>
-        <p:spPr>
-          <a:xfrm>
-            <a:off x="5486400" y="3383279"/>
-            <a:ext cx="914400" cy="365760"/>
-          </a:xfrm>
-          <a:prstGeom prst="rect">
-            <a:avLst/>
-          </a:prstGeom>
-          <a:noFill/>
-        </p:spPr>
-        <p:txBody>
-          <a:bodyPr wrap="square" anchor="t">
-            <a:spAutoFit/>
-          </a:bodyPr>
-          <a:lstStyle/>
-          <a:p>
-            <a:pPr algn="l">
-              <a:lnSpc>
-                <a:spcPct val="106000"/>
-              </a:lnSpc>
-              <a:spcBef>
-                <a:spcPts val="0"/>
-              </a:spcBef>
-              <a:spcAft>
-                <a:spcPts val="0"/>
-              </a:spcAft>
-            </a:pPr>
-            <a:r>
-              <a:rPr sz="1250" b="1">
-                <a:solidFill>
-                  <a:srgbClr val="C2410C"/>
-                </a:solidFill>
-                <a:latin typeface="Consolas"/>
-              </a:rPr>
-              <a:t>gap</a:t>
-            </a:r>
-          </a:p>
-        </p:txBody>
-      </p:sp>
-      <p:sp>
-        <p:nvSpPr>
-          <p:cNvPr id="11" name="TextBox 10"/>
-          <p:cNvSpPr txBox="1"/>
-          <p:nvPr/>
-        </p:nvSpPr>
-        <p:spPr>
-          <a:xfrm>
-            <a:off x="6400800" y="3364991"/>
-            <a:ext cx="4937760" cy="1005840"/>
-          </a:xfrm>
-          <a:prstGeom prst="rect">
-            <a:avLst/>
-          </a:prstGeom>
-          <a:noFill/>
-        </p:spPr>
-        <p:txBody>
-          <a:bodyPr wrap="square" anchor="t">
-            <a:spAutoFit/>
-          </a:bodyPr>
-          <a:lstStyle/>
-          <a:p>
-            <a:pPr algn="l">
-              <a:lnSpc>
-                <a:spcPct val="112000"/>
-              </a:lnSpc>
-              <a:spcBef>
-                <a:spcPts val="0"/>
-              </a:spcBef>
-              <a:spcAft>
-                <a:spcPts val="0"/>
-              </a:spcAft>
-            </a:pPr>
-            <a:r>
-              <a:rPr sz="1450" b="0">
-                <a:solidFill>
-                  <a:srgbClr val="5A616E"/>
-                </a:solidFill>
-                <a:latin typeface="Calibri"/>
-              </a:rPr>
-              <a:t>The pain isn't capturing what was said. It's doing what was decided.</a:t>
-            </a:r>
-          </a:p>
-        </p:txBody>
-      </p:sp>
-      <p:sp>
-        <p:nvSpPr>
-          <p:cNvPr id="12" name="TextBox 11"/>
-          <p:cNvSpPr txBox="1"/>
-          <p:nvPr/>
-        </p:nvSpPr>
-        <p:spPr>
-          <a:xfrm>
-            <a:off x="5486400" y="4434840"/>
-            <a:ext cx="914400" cy="365760"/>
-          </a:xfrm>
-          <a:prstGeom prst="rect">
-            <a:avLst/>
-          </a:prstGeom>
-          <a:noFill/>
-        </p:spPr>
-        <p:txBody>
-          <a:bodyPr wrap="square" anchor="t">
-            <a:spAutoFit/>
-          </a:bodyPr>
-          <a:lstStyle/>
-          <a:p>
-            <a:pPr algn="l">
-              <a:lnSpc>
-                <a:spcPct val="106000"/>
-              </a:lnSpc>
-              <a:spcBef>
-                <a:spcPts val="0"/>
-              </a:spcBef>
-              <a:spcAft>
-                <a:spcPts val="0"/>
-              </a:spcAft>
-            </a:pPr>
-            <a:r>
-              <a:rPr sz="1250" b="1">
-                <a:solidFill>
-                  <a:srgbClr val="C2410C"/>
-                </a:solidFill>
-                <a:latin typeface="Consolas"/>
-              </a:rPr>
-              <a:t>cost</a:t>
-            </a:r>
-          </a:p>
-        </p:txBody>
-      </p:sp>
-      <p:sp>
-        <p:nvSpPr>
-          <p:cNvPr id="13" name="TextBox 12"/>
-          <p:cNvSpPr txBox="1"/>
-          <p:nvPr/>
-        </p:nvSpPr>
-        <p:spPr>
-          <a:xfrm>
-            <a:off x="6400800" y="4416552"/>
-            <a:ext cx="4937760" cy="1005840"/>
-          </a:xfrm>
-          <a:prstGeom prst="rect">
-            <a:avLst/>
-          </a:prstGeom>
-          <a:noFill/>
-        </p:spPr>
-        <p:txBody>
-          <a:bodyPr wrap="square" anchor="t">
-            <a:spAutoFit/>
-          </a:bodyPr>
-          <a:lstStyle/>
-          <a:p>
-            <a:pPr algn="l">
-              <a:lnSpc>
-                <a:spcPct val="112000"/>
-              </a:lnSpc>
-              <a:spcBef>
-                <a:spcPts val="0"/>
-              </a:spcBef>
-              <a:spcAft>
-                <a:spcPts val="0"/>
-              </a:spcAft>
-            </a:pPr>
-            <a:r>
-              <a:rPr sz="1450" b="0">
-                <a:solidFill>
-                  <a:srgbClr val="5A616E"/>
-                </a:solidFill>
-                <a:latin typeface="Calibri"/>
-              </a:rPr>
-              <a:t>Dropped commitments = re-work, missed deadlines, and eroded trust.</a:t>
-            </a:r>
-          </a:p>
-        </p:txBody>
-      </p:sp>
-      <p:sp>
-        <p:nvSpPr>
-          <p:cNvPr id="14" name="TextBox 13"/>
-          <p:cNvSpPr txBox="1"/>
-          <p:nvPr/>
-        </p:nvSpPr>
-        <p:spPr>
-          <a:xfrm>
-            <a:off x="822960" y="6126480"/>
-            <a:ext cx="10515600" cy="457200"/>
-          </a:xfrm>
-          <a:prstGeom prst="rect">
-            <a:avLst/>
-          </a:prstGeom>
-          <a:noFill/>
-        </p:spPr>
-        <p:txBody>
-          <a:bodyPr wrap="square" anchor="t">
-            <a:spAutoFit/>
-          </a:bodyPr>
-          <a:lstStyle/>
-          <a:p>
-            <a:pPr algn="l">
-              <a:lnSpc>
-                <a:spcPct val="110000"/>
-              </a:lnSpc>
-              <a:spcBef>
-                <a:spcPts val="0"/>
-              </a:spcBef>
-              <a:spcAft>
-                <a:spcPts val="0"/>
-              </a:spcAft>
-            </a:pPr>
-            <a:r>
-              <a:rPr sz="1150" b="0">
-                <a:solidFill>
-                  <a:srgbClr val="8B919D"/>
-                </a:solidFill>
-                <a:latin typeface="Calibri"/>
-              </a:rPr>
-              <a:t>Industry estimates range ~44–73% never completed (Fellow, Streamli9). Directional — as PM, first job is to validate with first-party instrumentation before over-investing.</a:t>
+              <a:t>Real output from the live app — extracted in ~2.8s: summary, decisions, and one column per owner, each card one click from a prefilled Calendar event or Gmail draft.</a:t>
             </a:r>
           </a:p>
         </p:txBody>
@@ -6967,7 +6675,7 @@
                 </a:solidFill>
                 <a:latin typeface="Consolas"/>
               </a:rPr>
-              <a:t>02 · THE INSIGHT</a:t>
+              <a:t>01 · THE PRODUCT</a:t>
             </a:r>
           </a:p>
         </p:txBody>
@@ -7012,7 +6720,7 @@
                 </a:solidFill>
                 <a:latin typeface="Calibri"/>
               </a:rPr>
-              <a:t>Everyone is fighting over capture. The last mile is wide open.</a:t>
+              <a:t>Paste a meeting → get owned action → distribute in one click.</a:t>
             </a:r>
           </a:p>
         </p:txBody>
@@ -7025,8 +6733,8 @@
         </p:nvSpPr>
         <p:spPr>
           <a:xfrm>
-            <a:off x="822960" y="2286000"/>
-            <a:ext cx="5257800" cy="2148840"/>
+            <a:off x="822960" y="2331720"/>
+            <a:ext cx="3429000" cy="1828800"/>
           </a:xfrm>
           <a:prstGeom prst="roundRect">
             <a:avLst>
@@ -7073,8 +6781,8 @@
         </p:nvSpPr>
         <p:spPr>
           <a:xfrm>
-            <a:off x="1097280" y="2487168"/>
-            <a:ext cx="4754880" cy="365760"/>
+            <a:off x="1078992" y="2514600"/>
+            <a:ext cx="2971800" cy="365760"/>
           </a:xfrm>
           <a:prstGeom prst="rect">
             <a:avLst/>
@@ -7101,11 +6809,11 @@
             <a:r>
               <a:rPr sz="1100" b="1">
                 <a:solidFill>
-                  <a:srgbClr val="8B919D"/>
+                  <a:srgbClr val="C2410C"/>
                 </a:solidFill>
                 <a:latin typeface="Consolas"/>
               </a:rPr>
-              <a:t>CROWDED — “CAPTURE”</a:t>
+              <a:t>INPUT</a:t>
             </a:r>
           </a:p>
         </p:txBody>
@@ -7118,8 +6826,8 @@
         </p:nvSpPr>
         <p:spPr>
           <a:xfrm>
-            <a:off x="1097280" y="2907792"/>
-            <a:ext cx="4754880" cy="457200"/>
+            <a:off x="1078992" y="2880360"/>
+            <a:ext cx="2971800" cy="457200"/>
           </a:xfrm>
           <a:prstGeom prst="rect">
             <a:avLst/>
@@ -7144,13 +6852,13 @@
               </a:spcAft>
             </a:pPr>
             <a:r>
-              <a:rPr sz="1900" b="1">
+              <a:rPr sz="1700" b="1">
                 <a:solidFill>
                   <a:srgbClr val="16181F"/>
                 </a:solidFill>
                 <a:latin typeface="Calibri"/>
               </a:rPr>
-              <a:t>Transcribe &amp; summarize</a:t>
+              <a:t>Drop it in</a:t>
             </a:r>
           </a:p>
         </p:txBody>
@@ -7163,8 +6871,8 @@
         </p:nvSpPr>
         <p:spPr>
           <a:xfrm>
-            <a:off x="1097280" y="3429000"/>
-            <a:ext cx="4754880" cy="914400"/>
+            <a:off x="1078992" y="3383280"/>
+            <a:ext cx="2971800" cy="731520"/>
           </a:xfrm>
           <a:prstGeom prst="rect">
             <a:avLst/>
@@ -7189,13 +6897,13 @@
               </a:spcAft>
             </a:pPr>
             <a:r>
-              <a:rPr sz="1350" b="0">
+              <a:rPr sz="1300" b="0">
                 <a:solidFill>
                   <a:srgbClr val="5A616E"/>
                 </a:solidFill>
                 <a:latin typeface="Calibri"/>
               </a:rPr>
-              <a:t>Otter, Fireflies, Fathom, Granola — all competing on better transcripts. Table stakes now. The commitments they surface still die in a doc.</a:t>
+              <a:t>Paste a transcript, a public Google Doc URL, or a file. No account.</a:t>
             </a:r>
           </a:p>
         </p:txBody>
@@ -7208,8 +6916,8 @@
         </p:nvSpPr>
         <p:spPr>
           <a:xfrm>
-            <a:off x="6263640" y="2286000"/>
-            <a:ext cx="5120640" cy="2148840"/>
+            <a:off x="4434840" y="2331720"/>
+            <a:ext cx="3429000" cy="1828800"/>
           </a:xfrm>
           <a:prstGeom prst="roundRect">
             <a:avLst>
@@ -7217,11 +6925,11 @@
             </a:avLst>
           </a:prstGeom>
           <a:solidFill>
-            <a:srgbClr val="FBEFEA"/>
+            <a:srgbClr val="FFFFFF"/>
           </a:solidFill>
-          <a:ln w="17780">
+          <a:ln w="12700">
             <a:solidFill>
-              <a:srgbClr val="C2410C"/>
+              <a:srgbClr val="DEE1E7"/>
             </a:solidFill>
           </a:ln>
           <a:effectLst/>
@@ -7256,8 +6964,8 @@
         </p:nvSpPr>
         <p:spPr>
           <a:xfrm>
-            <a:off x="6537960" y="2487168"/>
-            <a:ext cx="4572000" cy="365760"/>
+            <a:off x="4690872" y="2514600"/>
+            <a:ext cx="2971800" cy="365760"/>
           </a:xfrm>
           <a:prstGeom prst="rect">
             <a:avLst/>
@@ -7288,7 +6996,7 @@
                 </a:solidFill>
                 <a:latin typeface="Consolas"/>
               </a:rPr>
-              <a:t>OPEN — “THE LAST MILE”</a:t>
+              <a:t>EXTRACT</a:t>
             </a:r>
           </a:p>
         </p:txBody>
@@ -7301,8 +7009,8 @@
         </p:nvSpPr>
         <p:spPr>
           <a:xfrm>
-            <a:off x="6537960" y="2907792"/>
-            <a:ext cx="4572000" cy="457200"/>
+            <a:off x="4690872" y="2880360"/>
+            <a:ext cx="2971800" cy="457200"/>
           </a:xfrm>
           <a:prstGeom prst="rect">
             <a:avLst/>
@@ -7327,13 +7035,13 @@
               </a:spcAft>
             </a:pPr>
             <a:r>
-              <a:rPr sz="1900" b="1">
+              <a:rPr sz="1700" b="1">
                 <a:solidFill>
                   <a:srgbClr val="16181F"/>
                 </a:solidFill>
                 <a:latin typeface="Calibri"/>
               </a:rPr>
-              <a:t>Distribute &amp; act</a:t>
+              <a:t>AI structures it</a:t>
             </a:r>
           </a:p>
         </p:txBody>
@@ -7346,8 +7054,8 @@
         </p:nvSpPr>
         <p:spPr>
           <a:xfrm>
-            <a:off x="6537960" y="3429000"/>
-            <a:ext cx="4572000" cy="914400"/>
+            <a:off x="4690872" y="3383280"/>
+            <a:ext cx="2971800" cy="731520"/>
           </a:xfrm>
           <a:prstGeom prst="rect">
             <a:avLst/>
@@ -7372,27 +7080,210 @@
               </a:spcAft>
             </a:pPr>
             <a:r>
-              <a:rPr sz="1350" b="0">
+              <a:rPr sz="1300" b="0">
                 <a:solidFill>
                   <a:srgbClr val="5A616E"/>
                 </a:solidFill>
                 <a:latin typeface="Calibri"/>
               </a:rPr>
-              <a:t>Getting each commitment into the tool the owner actually lives in — their calendar, their inbox — is where follow-through is won or lost.</a:t>
-            </a:r>
-          </a:p>
-        </p:txBody>
-      </p:sp>
-      <p:sp>
-        <p:nvSpPr>
-          <p:cNvPr id="14" name="Rectangle 13"/>
+              <a:t>Summary, decisions, and action items — each with owner, email, due date, context.</a:t>
+            </a:r>
+          </a:p>
+        </p:txBody>
+      </p:sp>
+      <p:sp>
+        <p:nvSpPr>
+          <p:cNvPr id="14" name="Rounded Rectangle 13"/>
           <p:cNvSpPr/>
           <p:nvPr/>
         </p:nvSpPr>
         <p:spPr>
           <a:xfrm>
-            <a:off x="822960" y="4892040"/>
-            <a:ext cx="54864" cy="1097280"/>
+            <a:off x="8046720" y="2331720"/>
+            <a:ext cx="3429000" cy="1828800"/>
+          </a:xfrm>
+          <a:prstGeom prst="roundRect">
+            <a:avLst>
+              <a:gd name="adj" fmla="val 4500"/>
+            </a:avLst>
+          </a:prstGeom>
+          <a:solidFill>
+            <a:srgbClr val="FFFFFF"/>
+          </a:solidFill>
+          <a:ln w="12700">
+            <a:solidFill>
+              <a:srgbClr val="DEE1E7"/>
+            </a:solidFill>
+          </a:ln>
+          <a:effectLst/>
+        </p:spPr>
+        <p:style>
+          <a:lnRef idx="1">
+            <a:schemeClr val="accent1"/>
+          </a:lnRef>
+          <a:fillRef idx="3">
+            <a:schemeClr val="accent1"/>
+          </a:fillRef>
+          <a:effectRef idx="2">
+            <a:schemeClr val="accent1"/>
+          </a:effectRef>
+          <a:fontRef idx="minor">
+            <a:schemeClr val="lt1"/>
+          </a:fontRef>
+        </p:style>
+        <p:txBody>
+          <a:bodyPr rtlCol="0" anchor="ctr"/>
+          <a:lstStyle/>
+          <a:p>
+            <a:pPr algn="ctr"/>
+          </a:p>
+        </p:txBody>
+      </p:sp>
+      <p:sp>
+        <p:nvSpPr>
+          <p:cNvPr id="15" name="TextBox 14"/>
+          <p:cNvSpPr txBox="1"/>
+          <p:nvPr/>
+        </p:nvSpPr>
+        <p:spPr>
+          <a:xfrm>
+            <a:off x="8302752" y="2514600"/>
+            <a:ext cx="2971800" cy="365760"/>
+          </a:xfrm>
+          <a:prstGeom prst="rect">
+            <a:avLst/>
+          </a:prstGeom>
+          <a:noFill/>
+        </p:spPr>
+        <p:txBody>
+          <a:bodyPr wrap="square" anchor="t">
+            <a:spAutoFit/>
+          </a:bodyPr>
+          <a:lstStyle/>
+          <a:p>
+            <a:pPr algn="l">
+              <a:lnSpc>
+                <a:spcPct val="106000"/>
+              </a:lnSpc>
+              <a:spcBef>
+                <a:spcPts val="0"/>
+              </a:spcBef>
+              <a:spcAft>
+                <a:spcPts val="0"/>
+              </a:spcAft>
+            </a:pPr>
+            <a:r>
+              <a:rPr sz="1100" b="1">
+                <a:solidFill>
+                  <a:srgbClr val="C2410C"/>
+                </a:solidFill>
+                <a:latin typeface="Consolas"/>
+              </a:rPr>
+              <a:t>DISTRIBUTE</a:t>
+            </a:r>
+          </a:p>
+        </p:txBody>
+      </p:sp>
+      <p:sp>
+        <p:nvSpPr>
+          <p:cNvPr id="16" name="TextBox 15"/>
+          <p:cNvSpPr txBox="1"/>
+          <p:nvPr/>
+        </p:nvSpPr>
+        <p:spPr>
+          <a:xfrm>
+            <a:off x="8302752" y="2880360"/>
+            <a:ext cx="2971800" cy="457200"/>
+          </a:xfrm>
+          <a:prstGeom prst="rect">
+            <a:avLst/>
+          </a:prstGeom>
+          <a:noFill/>
+        </p:spPr>
+        <p:txBody>
+          <a:bodyPr wrap="square" anchor="t">
+            <a:spAutoFit/>
+          </a:bodyPr>
+          <a:lstStyle/>
+          <a:p>
+            <a:pPr algn="l">
+              <a:lnSpc>
+                <a:spcPct val="106000"/>
+              </a:lnSpc>
+              <a:spcBef>
+                <a:spcPts val="0"/>
+              </a:spcBef>
+              <a:spcAft>
+                <a:spcPts val="0"/>
+              </a:spcAft>
+            </a:pPr>
+            <a:r>
+              <a:rPr sz="1700" b="1">
+                <a:solidFill>
+                  <a:srgbClr val="16181F"/>
+                </a:solidFill>
+                <a:latin typeface="Calibri"/>
+              </a:rPr>
+              <a:t>One-click send</a:t>
+            </a:r>
+          </a:p>
+        </p:txBody>
+      </p:sp>
+      <p:sp>
+        <p:nvSpPr>
+          <p:cNvPr id="17" name="TextBox 16"/>
+          <p:cNvSpPr txBox="1"/>
+          <p:nvPr/>
+        </p:nvSpPr>
+        <p:spPr>
+          <a:xfrm>
+            <a:off x="8302752" y="3383280"/>
+            <a:ext cx="2971800" cy="731520"/>
+          </a:xfrm>
+          <a:prstGeom prst="rect">
+            <a:avLst/>
+          </a:prstGeom>
+          <a:noFill/>
+        </p:spPr>
+        <p:txBody>
+          <a:bodyPr wrap="square" anchor="t">
+            <a:spAutoFit/>
+          </a:bodyPr>
+          <a:lstStyle/>
+          <a:p>
+            <a:pPr algn="l">
+              <a:lnSpc>
+                <a:spcPct val="112000"/>
+              </a:lnSpc>
+              <a:spcBef>
+                <a:spcPts val="0"/>
+              </a:spcBef>
+              <a:spcAft>
+                <a:spcPts val="0"/>
+              </a:spcAft>
+            </a:pPr>
+            <a:r>
+              <a:rPr sz="1300" b="0">
+                <a:solidFill>
+                  <a:srgbClr val="5A616E"/>
+                </a:solidFill>
+                <a:latin typeface="Calibri"/>
+              </a:rPr>
+              <a:t>Each item opens a prefilled Google Calendar event or Gmail draft. Just Save / Send.</a:t>
+            </a:r>
+          </a:p>
+        </p:txBody>
+      </p:sp>
+      <p:sp>
+        <p:nvSpPr>
+          <p:cNvPr id="18" name="Rectangle 17"/>
+          <p:cNvSpPr/>
+          <p:nvPr/>
+        </p:nvSpPr>
+        <p:spPr>
+          <a:xfrm>
+            <a:off x="822960" y="4617720"/>
+            <a:ext cx="54864" cy="1234440"/>
           </a:xfrm>
           <a:prstGeom prst="rect">
             <a:avLst/>
@@ -7429,14 +7320,14 @@
       </p:sp>
       <p:sp>
         <p:nvSpPr>
-          <p:cNvPr id="15" name="TextBox 14"/>
-          <p:cNvSpPr txBox="1"/>
-          <p:nvPr/>
-        </p:nvSpPr>
-        <p:spPr>
-          <a:xfrm>
-            <a:off x="1097280" y="4983480"/>
-            <a:ext cx="10241280" cy="1005840"/>
+          <p:cNvPr id="19" name="TextBox 18"/>
+          <p:cNvSpPr txBox="1"/>
+          <p:nvPr/>
+        </p:nvSpPr>
+        <p:spPr>
+          <a:xfrm>
+            <a:off x="1097280" y="4681728"/>
+            <a:ext cx="10241280" cy="1188720"/>
           </a:xfrm>
           <a:prstGeom prst="rect">
             <a:avLst/>
@@ -7461,31 +7352,22 @@
               </a:spcAft>
             </a:pPr>
             <a:r>
-              <a:rPr sz="2100" b="0">
+              <a:rPr sz="1800" b="0">
                 <a:solidFill>
                   <a:srgbClr val="16181F"/>
                 </a:solidFill>
                 <a:latin typeface="Calibri"/>
               </a:rPr>
-              <a:t>The blocker on the last mile isn't a smarter model — it's </a:t>
-            </a:r>
-            <a:r>
-              <a:rPr sz="2100" b="1">
+              <a:t>The “no-OAuth trick”: prefilled Calendar / Gmail URLs open in the user's already-logged-in Google. </a:t>
+            </a:r>
+            <a:r>
+              <a:rPr sz="1800" b="1">
                 <a:solidFill>
                   <a:srgbClr val="C2410C"/>
                 </a:solidFill>
                 <a:latin typeface="Calibri"/>
               </a:rPr>
-              <a:t>setup friction</a:t>
-            </a:r>
-            <a:r>
-              <a:rPr sz="2100" b="0">
-                <a:solidFill>
-                  <a:srgbClr val="16181F"/>
-                </a:solidFill>
-                <a:latin typeface="Calibri"/>
-              </a:rPr>
-              <a:t>. So the wedge is zero-setup distribution.</a:t>
+              <a:t>Time-to-value ~10 seconds — no integration, no admin approval, no scope review.</a:t>
             </a:r>
           </a:p>
         </p:txBody>
@@ -7636,7 +7518,7 @@
                 </a:solidFill>
                 <a:latin typeface="Consolas"/>
               </a:rPr>
-              <a:t>03 · THE PRODUCT</a:t>
+              <a:t>02 · THE PROBLEM</a:t>
             </a:r>
           </a:p>
         </p:txBody>
@@ -7681,56 +7563,53 @@
                 </a:solidFill>
                 <a:latin typeface="Calibri"/>
               </a:rPr>
-              <a:t>Paste a meeting → get owned action → distribute in one click.</a:t>
-            </a:r>
-          </a:p>
-        </p:txBody>
-      </p:sp>
-      <p:sp>
-        <p:nvSpPr>
-          <p:cNvPr id="6" name="Rounded Rectangle 5"/>
-          <p:cNvSpPr/>
-          <p:nvPr/>
-        </p:nvSpPr>
-        <p:spPr>
-          <a:xfrm>
-            <a:off x="822960" y="2331720"/>
-            <a:ext cx="3429000" cy="1828800"/>
-          </a:xfrm>
-          <a:prstGeom prst="roundRect">
-            <a:avLst>
-              <a:gd name="adj" fmla="val 4500"/>
-            </a:avLst>
-          </a:prstGeom>
-          <a:solidFill>
-            <a:srgbClr val="FFFFFF"/>
-          </a:solidFill>
-          <a:ln w="12700">
-            <a:solidFill>
-              <a:srgbClr val="DEE1E7"/>
-            </a:solidFill>
-          </a:ln>
-          <a:effectLst/>
-        </p:spPr>
-        <p:style>
-          <a:lnRef idx="1">
-            <a:schemeClr val="accent1"/>
-          </a:lnRef>
-          <a:fillRef idx="3">
-            <a:schemeClr val="accent1"/>
-          </a:fillRef>
-          <a:effectRef idx="2">
-            <a:schemeClr val="accent1"/>
-          </a:effectRef>
-          <a:fontRef idx="minor">
-            <a:schemeClr val="lt1"/>
-          </a:fontRef>
-        </p:style>
-        <p:txBody>
-          <a:bodyPr rtlCol="0" anchor="ctr"/>
-          <a:lstStyle/>
-          <a:p>
-            <a:pPr algn="ctr"/>
+              <a:t>Meetings manufacture commitments. Then the commitments go missing.</a:t>
+            </a:r>
+          </a:p>
+        </p:txBody>
+      </p:sp>
+      <p:sp>
+        <p:nvSpPr>
+          <p:cNvPr id="6" name="TextBox 5"/>
+          <p:cNvSpPr txBox="1"/>
+          <p:nvPr/>
+        </p:nvSpPr>
+        <p:spPr>
+          <a:xfrm>
+            <a:off x="822960" y="2286000"/>
+            <a:ext cx="4023360" cy="1280160"/>
+          </a:xfrm>
+          <a:prstGeom prst="rect">
+            <a:avLst/>
+          </a:prstGeom>
+          <a:noFill/>
+        </p:spPr>
+        <p:txBody>
+          <a:bodyPr wrap="square" anchor="t">
+            <a:spAutoFit/>
+          </a:bodyPr>
+          <a:lstStyle/>
+          <a:p>
+            <a:pPr algn="l">
+              <a:lnSpc>
+                <a:spcPct val="106000"/>
+              </a:lnSpc>
+              <a:spcBef>
+                <a:spcPts val="0"/>
+              </a:spcBef>
+              <a:spcAft>
+                <a:spcPts val="0"/>
+              </a:spcAft>
+            </a:pPr>
+            <a:r>
+              <a:rPr sz="6600" b="1">
+                <a:solidFill>
+                  <a:srgbClr val="C2410C"/>
+                </a:solidFill>
+                <a:latin typeface="Calibri"/>
+              </a:rPr>
+              <a:t>~70%</a:t>
+            </a:r>
           </a:p>
         </p:txBody>
       </p:sp>
@@ -7742,8 +7621,53 @@
         </p:nvSpPr>
         <p:spPr>
           <a:xfrm>
-            <a:off x="1078992" y="2514600"/>
-            <a:ext cx="2971800" cy="365760"/>
+            <a:off x="822960" y="3566160"/>
+            <a:ext cx="4480560" cy="1737360"/>
+          </a:xfrm>
+          <a:prstGeom prst="rect">
+            <a:avLst/>
+          </a:prstGeom>
+          <a:noFill/>
+        </p:spPr>
+        <p:txBody>
+          <a:bodyPr wrap="square" anchor="t">
+            <a:spAutoFit/>
+          </a:bodyPr>
+          <a:lstStyle/>
+          <a:p>
+            <a:pPr algn="l">
+              <a:lnSpc>
+                <a:spcPct val="116000"/>
+              </a:lnSpc>
+              <a:spcBef>
+                <a:spcPts val="0"/>
+              </a:spcBef>
+              <a:spcAft>
+                <a:spcPts val="0"/>
+              </a:spcAft>
+            </a:pPr>
+            <a:r>
+              <a:rPr sz="1550" b="0">
+                <a:solidFill>
+                  <a:srgbClr val="5A616E"/>
+                </a:solidFill>
+                <a:latin typeface="Calibri"/>
+              </a:rPr>
+              <a:t>of meeting action items are never completed — they live in someone's notes, a Slack thread, a doc nobody reopens.</a:t>
+            </a:r>
+          </a:p>
+        </p:txBody>
+      </p:sp>
+      <p:sp>
+        <p:nvSpPr>
+          <p:cNvPr id="8" name="TextBox 7"/>
+          <p:cNvSpPr txBox="1"/>
+          <p:nvPr/>
+        </p:nvSpPr>
+        <p:spPr>
+          <a:xfrm>
+            <a:off x="5486400" y="2331720"/>
+            <a:ext cx="914400" cy="365760"/>
           </a:xfrm>
           <a:prstGeom prst="rect">
             <a:avLst/>
@@ -7768,27 +7692,72 @@
               </a:spcAft>
             </a:pPr>
             <a:r>
-              <a:rPr sz="1100" b="1">
+              <a:rPr sz="1250" b="1">
                 <a:solidFill>
                   <a:srgbClr val="C2410C"/>
                 </a:solidFill>
                 <a:latin typeface="Consolas"/>
               </a:rPr>
-              <a:t>INPUT</a:t>
-            </a:r>
-          </a:p>
-        </p:txBody>
-      </p:sp>
-      <p:sp>
-        <p:nvSpPr>
-          <p:cNvPr id="8" name="TextBox 7"/>
-          <p:cNvSpPr txBox="1"/>
-          <p:nvPr/>
-        </p:nvSpPr>
-        <p:spPr>
-          <a:xfrm>
-            <a:off x="1078992" y="2880360"/>
-            <a:ext cx="2971800" cy="457200"/>
+              <a:t>who</a:t>
+            </a:r>
+          </a:p>
+        </p:txBody>
+      </p:sp>
+      <p:sp>
+        <p:nvSpPr>
+          <p:cNvPr id="9" name="TextBox 8"/>
+          <p:cNvSpPr txBox="1"/>
+          <p:nvPr/>
+        </p:nvSpPr>
+        <p:spPr>
+          <a:xfrm>
+            <a:off x="6400800" y="2313432"/>
+            <a:ext cx="4937760" cy="1005840"/>
+          </a:xfrm>
+          <a:prstGeom prst="rect">
+            <a:avLst/>
+          </a:prstGeom>
+          <a:noFill/>
+        </p:spPr>
+        <p:txBody>
+          <a:bodyPr wrap="square" anchor="t">
+            <a:spAutoFit/>
+          </a:bodyPr>
+          <a:lstStyle/>
+          <a:p>
+            <a:pPr algn="l">
+              <a:lnSpc>
+                <a:spcPct val="112000"/>
+              </a:lnSpc>
+              <a:spcBef>
+                <a:spcPts val="0"/>
+              </a:spcBef>
+              <a:spcAft>
+                <a:spcPts val="0"/>
+              </a:spcAft>
+            </a:pPr>
+            <a:r>
+              <a:rPr sz="1450" b="0">
+                <a:solidFill>
+                  <a:srgbClr val="5A616E"/>
+                </a:solidFill>
+                <a:latin typeface="Calibri"/>
+              </a:rPr>
+              <a:t>Knowledge workers spend a huge share of the week in meetings — what matters is the follow-through, not the recording.</a:t>
+            </a:r>
+          </a:p>
+        </p:txBody>
+      </p:sp>
+      <p:sp>
+        <p:nvSpPr>
+          <p:cNvPr id="10" name="TextBox 9"/>
+          <p:cNvSpPr txBox="1"/>
+          <p:nvPr/>
+        </p:nvSpPr>
+        <p:spPr>
+          <a:xfrm>
+            <a:off x="5486400" y="3383279"/>
+            <a:ext cx="914400" cy="365760"/>
           </a:xfrm>
           <a:prstGeom prst="rect">
             <a:avLst/>
@@ -7813,27 +7782,117 @@
               </a:spcAft>
             </a:pPr>
             <a:r>
-              <a:rPr sz="1700" b="1">
-                <a:solidFill>
-                  <a:srgbClr val="16181F"/>
+              <a:rPr sz="1250" b="1">
+                <a:solidFill>
+                  <a:srgbClr val="C2410C"/>
+                </a:solidFill>
+                <a:latin typeface="Consolas"/>
+              </a:rPr>
+              <a:t>gap</a:t>
+            </a:r>
+          </a:p>
+        </p:txBody>
+      </p:sp>
+      <p:sp>
+        <p:nvSpPr>
+          <p:cNvPr id="11" name="TextBox 10"/>
+          <p:cNvSpPr txBox="1"/>
+          <p:nvPr/>
+        </p:nvSpPr>
+        <p:spPr>
+          <a:xfrm>
+            <a:off x="6400800" y="3364991"/>
+            <a:ext cx="4937760" cy="1005840"/>
+          </a:xfrm>
+          <a:prstGeom prst="rect">
+            <a:avLst/>
+          </a:prstGeom>
+          <a:noFill/>
+        </p:spPr>
+        <p:txBody>
+          <a:bodyPr wrap="square" anchor="t">
+            <a:spAutoFit/>
+          </a:bodyPr>
+          <a:lstStyle/>
+          <a:p>
+            <a:pPr algn="l">
+              <a:lnSpc>
+                <a:spcPct val="112000"/>
+              </a:lnSpc>
+              <a:spcBef>
+                <a:spcPts val="0"/>
+              </a:spcBef>
+              <a:spcAft>
+                <a:spcPts val="0"/>
+              </a:spcAft>
+            </a:pPr>
+            <a:r>
+              <a:rPr sz="1450" b="0">
+                <a:solidFill>
+                  <a:srgbClr val="5A616E"/>
                 </a:solidFill>
                 <a:latin typeface="Calibri"/>
               </a:rPr>
-              <a:t>Drop it in</a:t>
-            </a:r>
-          </a:p>
-        </p:txBody>
-      </p:sp>
-      <p:sp>
-        <p:nvSpPr>
-          <p:cNvPr id="9" name="TextBox 8"/>
-          <p:cNvSpPr txBox="1"/>
-          <p:nvPr/>
-        </p:nvSpPr>
-        <p:spPr>
-          <a:xfrm>
-            <a:off x="1078992" y="3383280"/>
-            <a:ext cx="2971800" cy="731520"/>
+              <a:t>The pain isn't capturing what was said. It's doing what was decided.</a:t>
+            </a:r>
+          </a:p>
+        </p:txBody>
+      </p:sp>
+      <p:sp>
+        <p:nvSpPr>
+          <p:cNvPr id="12" name="TextBox 11"/>
+          <p:cNvSpPr txBox="1"/>
+          <p:nvPr/>
+        </p:nvSpPr>
+        <p:spPr>
+          <a:xfrm>
+            <a:off x="5486400" y="4434840"/>
+            <a:ext cx="914400" cy="365760"/>
+          </a:xfrm>
+          <a:prstGeom prst="rect">
+            <a:avLst/>
+          </a:prstGeom>
+          <a:noFill/>
+        </p:spPr>
+        <p:txBody>
+          <a:bodyPr wrap="square" anchor="t">
+            <a:spAutoFit/>
+          </a:bodyPr>
+          <a:lstStyle/>
+          <a:p>
+            <a:pPr algn="l">
+              <a:lnSpc>
+                <a:spcPct val="106000"/>
+              </a:lnSpc>
+              <a:spcBef>
+                <a:spcPts val="0"/>
+              </a:spcBef>
+              <a:spcAft>
+                <a:spcPts val="0"/>
+              </a:spcAft>
+            </a:pPr>
+            <a:r>
+              <a:rPr sz="1250" b="1">
+                <a:solidFill>
+                  <a:srgbClr val="C2410C"/>
+                </a:solidFill>
+                <a:latin typeface="Consolas"/>
+              </a:rPr>
+              <a:t>cost</a:t>
+            </a:r>
+          </a:p>
+        </p:txBody>
+      </p:sp>
+      <p:sp>
+        <p:nvSpPr>
+          <p:cNvPr id="13" name="TextBox 12"/>
+          <p:cNvSpPr txBox="1"/>
+          <p:nvPr/>
+        </p:nvSpPr>
+        <p:spPr>
+          <a:xfrm>
+            <a:off x="6400800" y="4416552"/>
+            <a:ext cx="4937760" cy="1005840"/>
           </a:xfrm>
           <a:prstGeom prst="rect">
             <a:avLst/>
@@ -7858,477 +7917,58 @@
               </a:spcAft>
             </a:pPr>
             <a:r>
-              <a:rPr sz="1300" b="0">
+              <a:rPr sz="1450" b="0">
                 <a:solidFill>
                   <a:srgbClr val="5A616E"/>
                 </a:solidFill>
                 <a:latin typeface="Calibri"/>
               </a:rPr>
-              <a:t>Paste a transcript, a public Google Doc URL, or a file. No account.</a:t>
-            </a:r>
-          </a:p>
-        </p:txBody>
-      </p:sp>
-      <p:sp>
-        <p:nvSpPr>
-          <p:cNvPr id="10" name="Rounded Rectangle 9"/>
-          <p:cNvSpPr/>
-          <p:nvPr/>
-        </p:nvSpPr>
-        <p:spPr>
-          <a:xfrm>
-            <a:off x="4434840" y="2331720"/>
-            <a:ext cx="3429000" cy="1828800"/>
-          </a:xfrm>
-          <a:prstGeom prst="roundRect">
-            <a:avLst>
-              <a:gd name="adj" fmla="val 4500"/>
-            </a:avLst>
-          </a:prstGeom>
-          <a:solidFill>
-            <a:srgbClr val="FFFFFF"/>
-          </a:solidFill>
-          <a:ln w="12700">
-            <a:solidFill>
-              <a:srgbClr val="DEE1E7"/>
-            </a:solidFill>
-          </a:ln>
-          <a:effectLst/>
-        </p:spPr>
-        <p:style>
-          <a:lnRef idx="1">
-            <a:schemeClr val="accent1"/>
-          </a:lnRef>
-          <a:fillRef idx="3">
-            <a:schemeClr val="accent1"/>
-          </a:fillRef>
-          <a:effectRef idx="2">
-            <a:schemeClr val="accent1"/>
-          </a:effectRef>
-          <a:fontRef idx="minor">
-            <a:schemeClr val="lt1"/>
-          </a:fontRef>
-        </p:style>
-        <p:txBody>
-          <a:bodyPr rtlCol="0" anchor="ctr"/>
-          <a:lstStyle/>
-          <a:p>
-            <a:pPr algn="ctr"/>
-          </a:p>
-        </p:txBody>
-      </p:sp>
-      <p:sp>
-        <p:nvSpPr>
-          <p:cNvPr id="11" name="TextBox 10"/>
-          <p:cNvSpPr txBox="1"/>
-          <p:nvPr/>
-        </p:nvSpPr>
-        <p:spPr>
-          <a:xfrm>
-            <a:off x="4690872" y="2514600"/>
-            <a:ext cx="2971800" cy="365760"/>
-          </a:xfrm>
-          <a:prstGeom prst="rect">
-            <a:avLst/>
-          </a:prstGeom>
-          <a:noFill/>
-        </p:spPr>
-        <p:txBody>
-          <a:bodyPr wrap="square" anchor="t">
-            <a:spAutoFit/>
-          </a:bodyPr>
-          <a:lstStyle/>
-          <a:p>
-            <a:pPr algn="l">
-              <a:lnSpc>
-                <a:spcPct val="106000"/>
-              </a:lnSpc>
-              <a:spcBef>
-                <a:spcPts val="0"/>
-              </a:spcBef>
-              <a:spcAft>
-                <a:spcPts val="0"/>
-              </a:spcAft>
-            </a:pPr>
-            <a:r>
-              <a:rPr sz="1100" b="1">
-                <a:solidFill>
-                  <a:srgbClr val="C2410C"/>
-                </a:solidFill>
-                <a:latin typeface="Consolas"/>
-              </a:rPr>
-              <a:t>EXTRACT</a:t>
-            </a:r>
-          </a:p>
-        </p:txBody>
-      </p:sp>
-      <p:sp>
-        <p:nvSpPr>
-          <p:cNvPr id="12" name="TextBox 11"/>
-          <p:cNvSpPr txBox="1"/>
-          <p:nvPr/>
-        </p:nvSpPr>
-        <p:spPr>
-          <a:xfrm>
-            <a:off x="4690872" y="2880360"/>
-            <a:ext cx="2971800" cy="457200"/>
-          </a:xfrm>
-          <a:prstGeom prst="rect">
-            <a:avLst/>
-          </a:prstGeom>
-          <a:noFill/>
-        </p:spPr>
-        <p:txBody>
-          <a:bodyPr wrap="square" anchor="t">
-            <a:spAutoFit/>
-          </a:bodyPr>
-          <a:lstStyle/>
-          <a:p>
-            <a:pPr algn="l">
-              <a:lnSpc>
-                <a:spcPct val="106000"/>
-              </a:lnSpc>
-              <a:spcBef>
-                <a:spcPts val="0"/>
-              </a:spcBef>
-              <a:spcAft>
-                <a:spcPts val="0"/>
-              </a:spcAft>
-            </a:pPr>
-            <a:r>
-              <a:rPr sz="1700" b="1">
-                <a:solidFill>
-                  <a:srgbClr val="16181F"/>
+              <a:t>Dropped commitments = re-work, missed deadlines, and eroded trust.</a:t>
+            </a:r>
+          </a:p>
+        </p:txBody>
+      </p:sp>
+      <p:sp>
+        <p:nvSpPr>
+          <p:cNvPr id="14" name="TextBox 13"/>
+          <p:cNvSpPr txBox="1"/>
+          <p:nvPr/>
+        </p:nvSpPr>
+        <p:spPr>
+          <a:xfrm>
+            <a:off x="822960" y="6126480"/>
+            <a:ext cx="10515600" cy="457200"/>
+          </a:xfrm>
+          <a:prstGeom prst="rect">
+            <a:avLst/>
+          </a:prstGeom>
+          <a:noFill/>
+        </p:spPr>
+        <p:txBody>
+          <a:bodyPr wrap="square" anchor="t">
+            <a:spAutoFit/>
+          </a:bodyPr>
+          <a:lstStyle/>
+          <a:p>
+            <a:pPr algn="l">
+              <a:lnSpc>
+                <a:spcPct val="110000"/>
+              </a:lnSpc>
+              <a:spcBef>
+                <a:spcPts val="0"/>
+              </a:spcBef>
+              <a:spcAft>
+                <a:spcPts val="0"/>
+              </a:spcAft>
+            </a:pPr>
+            <a:r>
+              <a:rPr sz="1150" b="0">
+                <a:solidFill>
+                  <a:srgbClr val="8B919D"/>
                 </a:solidFill>
                 <a:latin typeface="Calibri"/>
               </a:rPr>
-              <a:t>AI structures it</a:t>
-            </a:r>
-          </a:p>
-        </p:txBody>
-      </p:sp>
-      <p:sp>
-        <p:nvSpPr>
-          <p:cNvPr id="13" name="TextBox 12"/>
-          <p:cNvSpPr txBox="1"/>
-          <p:nvPr/>
-        </p:nvSpPr>
-        <p:spPr>
-          <a:xfrm>
-            <a:off x="4690872" y="3383280"/>
-            <a:ext cx="2971800" cy="731520"/>
-          </a:xfrm>
-          <a:prstGeom prst="rect">
-            <a:avLst/>
-          </a:prstGeom>
-          <a:noFill/>
-        </p:spPr>
-        <p:txBody>
-          <a:bodyPr wrap="square" anchor="t">
-            <a:spAutoFit/>
-          </a:bodyPr>
-          <a:lstStyle/>
-          <a:p>
-            <a:pPr algn="l">
-              <a:lnSpc>
-                <a:spcPct val="112000"/>
-              </a:lnSpc>
-              <a:spcBef>
-                <a:spcPts val="0"/>
-              </a:spcBef>
-              <a:spcAft>
-                <a:spcPts val="0"/>
-              </a:spcAft>
-            </a:pPr>
-            <a:r>
-              <a:rPr sz="1300" b="0">
-                <a:solidFill>
-                  <a:srgbClr val="5A616E"/>
-                </a:solidFill>
-                <a:latin typeface="Calibri"/>
-              </a:rPr>
-              <a:t>Summary, decisions, and action items — each with owner, email, due date, context.</a:t>
-            </a:r>
-          </a:p>
-        </p:txBody>
-      </p:sp>
-      <p:sp>
-        <p:nvSpPr>
-          <p:cNvPr id="14" name="Rounded Rectangle 13"/>
-          <p:cNvSpPr/>
-          <p:nvPr/>
-        </p:nvSpPr>
-        <p:spPr>
-          <a:xfrm>
-            <a:off x="8046720" y="2331720"/>
-            <a:ext cx="3429000" cy="1828800"/>
-          </a:xfrm>
-          <a:prstGeom prst="roundRect">
-            <a:avLst>
-              <a:gd name="adj" fmla="val 4500"/>
-            </a:avLst>
-          </a:prstGeom>
-          <a:solidFill>
-            <a:srgbClr val="FFFFFF"/>
-          </a:solidFill>
-          <a:ln w="12700">
-            <a:solidFill>
-              <a:srgbClr val="DEE1E7"/>
-            </a:solidFill>
-          </a:ln>
-          <a:effectLst/>
-        </p:spPr>
-        <p:style>
-          <a:lnRef idx="1">
-            <a:schemeClr val="accent1"/>
-          </a:lnRef>
-          <a:fillRef idx="3">
-            <a:schemeClr val="accent1"/>
-          </a:fillRef>
-          <a:effectRef idx="2">
-            <a:schemeClr val="accent1"/>
-          </a:effectRef>
-          <a:fontRef idx="minor">
-            <a:schemeClr val="lt1"/>
-          </a:fontRef>
-        </p:style>
-        <p:txBody>
-          <a:bodyPr rtlCol="0" anchor="ctr"/>
-          <a:lstStyle/>
-          <a:p>
-            <a:pPr algn="ctr"/>
-          </a:p>
-        </p:txBody>
-      </p:sp>
-      <p:sp>
-        <p:nvSpPr>
-          <p:cNvPr id="15" name="TextBox 14"/>
-          <p:cNvSpPr txBox="1"/>
-          <p:nvPr/>
-        </p:nvSpPr>
-        <p:spPr>
-          <a:xfrm>
-            <a:off x="8302752" y="2514600"/>
-            <a:ext cx="2971800" cy="365760"/>
-          </a:xfrm>
-          <a:prstGeom prst="rect">
-            <a:avLst/>
-          </a:prstGeom>
-          <a:noFill/>
-        </p:spPr>
-        <p:txBody>
-          <a:bodyPr wrap="square" anchor="t">
-            <a:spAutoFit/>
-          </a:bodyPr>
-          <a:lstStyle/>
-          <a:p>
-            <a:pPr algn="l">
-              <a:lnSpc>
-                <a:spcPct val="106000"/>
-              </a:lnSpc>
-              <a:spcBef>
-                <a:spcPts val="0"/>
-              </a:spcBef>
-              <a:spcAft>
-                <a:spcPts val="0"/>
-              </a:spcAft>
-            </a:pPr>
-            <a:r>
-              <a:rPr sz="1100" b="1">
-                <a:solidFill>
-                  <a:srgbClr val="C2410C"/>
-                </a:solidFill>
-                <a:latin typeface="Consolas"/>
-              </a:rPr>
-              <a:t>DISTRIBUTE</a:t>
-            </a:r>
-          </a:p>
-        </p:txBody>
-      </p:sp>
-      <p:sp>
-        <p:nvSpPr>
-          <p:cNvPr id="16" name="TextBox 15"/>
-          <p:cNvSpPr txBox="1"/>
-          <p:nvPr/>
-        </p:nvSpPr>
-        <p:spPr>
-          <a:xfrm>
-            <a:off x="8302752" y="2880360"/>
-            <a:ext cx="2971800" cy="457200"/>
-          </a:xfrm>
-          <a:prstGeom prst="rect">
-            <a:avLst/>
-          </a:prstGeom>
-          <a:noFill/>
-        </p:spPr>
-        <p:txBody>
-          <a:bodyPr wrap="square" anchor="t">
-            <a:spAutoFit/>
-          </a:bodyPr>
-          <a:lstStyle/>
-          <a:p>
-            <a:pPr algn="l">
-              <a:lnSpc>
-                <a:spcPct val="106000"/>
-              </a:lnSpc>
-              <a:spcBef>
-                <a:spcPts val="0"/>
-              </a:spcBef>
-              <a:spcAft>
-                <a:spcPts val="0"/>
-              </a:spcAft>
-            </a:pPr>
-            <a:r>
-              <a:rPr sz="1700" b="1">
-                <a:solidFill>
-                  <a:srgbClr val="16181F"/>
-                </a:solidFill>
-                <a:latin typeface="Calibri"/>
-              </a:rPr>
-              <a:t>One-click send</a:t>
-            </a:r>
-          </a:p>
-        </p:txBody>
-      </p:sp>
-      <p:sp>
-        <p:nvSpPr>
-          <p:cNvPr id="17" name="TextBox 16"/>
-          <p:cNvSpPr txBox="1"/>
-          <p:nvPr/>
-        </p:nvSpPr>
-        <p:spPr>
-          <a:xfrm>
-            <a:off x="8302752" y="3383280"/>
-            <a:ext cx="2971800" cy="731520"/>
-          </a:xfrm>
-          <a:prstGeom prst="rect">
-            <a:avLst/>
-          </a:prstGeom>
-          <a:noFill/>
-        </p:spPr>
-        <p:txBody>
-          <a:bodyPr wrap="square" anchor="t">
-            <a:spAutoFit/>
-          </a:bodyPr>
-          <a:lstStyle/>
-          <a:p>
-            <a:pPr algn="l">
-              <a:lnSpc>
-                <a:spcPct val="112000"/>
-              </a:lnSpc>
-              <a:spcBef>
-                <a:spcPts val="0"/>
-              </a:spcBef>
-              <a:spcAft>
-                <a:spcPts val="0"/>
-              </a:spcAft>
-            </a:pPr>
-            <a:r>
-              <a:rPr sz="1300" b="0">
-                <a:solidFill>
-                  <a:srgbClr val="5A616E"/>
-                </a:solidFill>
-                <a:latin typeface="Calibri"/>
-              </a:rPr>
-              <a:t>Each item opens a prefilled Google Calendar event or Gmail draft. Just Save / Send.</a:t>
-            </a:r>
-          </a:p>
-        </p:txBody>
-      </p:sp>
-      <p:sp>
-        <p:nvSpPr>
-          <p:cNvPr id="18" name="Rectangle 17"/>
-          <p:cNvSpPr/>
-          <p:nvPr/>
-        </p:nvSpPr>
-        <p:spPr>
-          <a:xfrm>
-            <a:off x="822960" y="4617720"/>
-            <a:ext cx="54864" cy="1234440"/>
-          </a:xfrm>
-          <a:prstGeom prst="rect">
-            <a:avLst/>
-          </a:prstGeom>
-          <a:solidFill>
-            <a:srgbClr val="C2410C"/>
-          </a:solidFill>
-          <a:ln>
-            <a:noFill/>
-          </a:ln>
-          <a:effectLst/>
-        </p:spPr>
-        <p:style>
-          <a:lnRef idx="1">
-            <a:schemeClr val="accent1"/>
-          </a:lnRef>
-          <a:fillRef idx="3">
-            <a:schemeClr val="accent1"/>
-          </a:fillRef>
-          <a:effectRef idx="2">
-            <a:schemeClr val="accent1"/>
-          </a:effectRef>
-          <a:fontRef idx="minor">
-            <a:schemeClr val="lt1"/>
-          </a:fontRef>
-        </p:style>
-        <p:txBody>
-          <a:bodyPr rtlCol="0" anchor="ctr"/>
-          <a:lstStyle/>
-          <a:p>
-            <a:pPr algn="ctr"/>
-          </a:p>
-        </p:txBody>
-      </p:sp>
-      <p:sp>
-        <p:nvSpPr>
-          <p:cNvPr id="19" name="TextBox 18"/>
-          <p:cNvSpPr txBox="1"/>
-          <p:nvPr/>
-        </p:nvSpPr>
-        <p:spPr>
-          <a:xfrm>
-            <a:off x="1097280" y="4681728"/>
-            <a:ext cx="10241280" cy="1188720"/>
-          </a:xfrm>
-          <a:prstGeom prst="rect">
-            <a:avLst/>
-          </a:prstGeom>
-          <a:noFill/>
-        </p:spPr>
-        <p:txBody>
-          <a:bodyPr wrap="square" anchor="t">
-            <a:spAutoFit/>
-          </a:bodyPr>
-          <a:lstStyle/>
-          <a:p>
-            <a:pPr algn="l">
-              <a:lnSpc>
-                <a:spcPct val="114000"/>
-              </a:lnSpc>
-              <a:spcBef>
-                <a:spcPts val="0"/>
-              </a:spcBef>
-              <a:spcAft>
-                <a:spcPts val="0"/>
-              </a:spcAft>
-            </a:pPr>
-            <a:r>
-              <a:rPr sz="1800" b="0">
-                <a:solidFill>
-                  <a:srgbClr val="16181F"/>
-                </a:solidFill>
-                <a:latin typeface="Calibri"/>
-              </a:rPr>
-              <a:t>The “no-OAuth trick”: prefilled Calendar / Gmail URLs open in the user's already-logged-in Google. </a:t>
-            </a:r>
-            <a:r>
-              <a:rPr sz="1800" b="1">
-                <a:solidFill>
-                  <a:srgbClr val="C2410C"/>
-                </a:solidFill>
-                <a:latin typeface="Calibri"/>
-              </a:rPr>
-              <a:t>Time-to-value ~10 seconds — no integration, no admin approval, no scope review.</a:t>
+              <a:t>Industry estimates range ~44–73% never completed (Fellow, Streamli9). Directional — as PM, first job is to validate with first-party instrumentation before over-investing.</a:t>
             </a:r>
           </a:p>
         </p:txBody>
@@ -8479,7 +8119,7 @@
                 </a:solidFill>
                 <a:latin typeface="Consolas"/>
               </a:rPr>
-              <a:t>—  SEE IT WORK</a:t>
+              <a:t>03 · THE INSIGHT</a:t>
             </a:r>
           </a:p>
         </p:txBody>
@@ -8518,56 +8158,36 @@
               </a:spcAft>
             </a:pPr>
             <a:r>
-              <a:rPr sz="2800" b="1">
+              <a:rPr sz="3300" b="1">
                 <a:solidFill>
                   <a:srgbClr val="16181F"/>
                 </a:solidFill>
                 <a:latin typeface="Calibri"/>
               </a:rPr>
-              <a:t>Paste a transcript → the board writes itself.</a:t>
-            </a:r>
-          </a:p>
-        </p:txBody>
-      </p:sp>
-      <p:pic>
-        <p:nvPicPr>
-          <p:cNvPr id="6" name="Picture 5" descr="postmeet-screenshot.png"/>
-          <p:cNvPicPr>
-            <a:picLocks noChangeAspect="1"/>
-          </p:cNvPicPr>
-          <p:nvPr/>
-        </p:nvPicPr>
-        <p:blipFill>
-          <a:blip r:embed="rId2"/>
-          <a:stretch>
-            <a:fillRect/>
-          </a:stretch>
-        </p:blipFill>
-        <p:spPr>
-          <a:xfrm>
-            <a:off x="3013488" y="1645920"/>
-            <a:ext cx="6164719" cy="4709160"/>
-          </a:xfrm>
-          <a:prstGeom prst="rect">
-            <a:avLst/>
-          </a:prstGeom>
-        </p:spPr>
-      </p:pic>
-      <p:sp>
-        <p:nvSpPr>
-          <p:cNvPr id="7" name="Rectangle 6"/>
+              <a:t>Everyone is fighting over capture. The last mile is wide open.</a:t>
+            </a:r>
+          </a:p>
+        </p:txBody>
+      </p:sp>
+      <p:sp>
+        <p:nvSpPr>
+          <p:cNvPr id="6" name="Rounded Rectangle 5"/>
           <p:cNvSpPr/>
           <p:nvPr/>
         </p:nvSpPr>
         <p:spPr>
           <a:xfrm>
-            <a:off x="3013488" y="1645920"/>
-            <a:ext cx="6164718" cy="4709160"/>
-          </a:xfrm>
-          <a:prstGeom prst="rect">
-            <a:avLst/>
-          </a:prstGeom>
-          <a:noFill/>
+            <a:off x="822960" y="2286000"/>
+            <a:ext cx="5257800" cy="2148840"/>
+          </a:xfrm>
+          <a:prstGeom prst="roundRect">
+            <a:avLst>
+              <a:gd name="adj" fmla="val 4500"/>
+            </a:avLst>
+          </a:prstGeom>
+          <a:solidFill>
+            <a:srgbClr val="FFFFFF"/>
+          </a:solidFill>
           <a:ln w="12700">
             <a:solidFill>
               <a:srgbClr val="DEE1E7"/>
@@ -8599,14 +8219,59 @@
       </p:sp>
       <p:sp>
         <p:nvSpPr>
+          <p:cNvPr id="7" name="TextBox 6"/>
+          <p:cNvSpPr txBox="1"/>
+          <p:nvPr/>
+        </p:nvSpPr>
+        <p:spPr>
+          <a:xfrm>
+            <a:off x="1097280" y="2487168"/>
+            <a:ext cx="4754880" cy="365760"/>
+          </a:xfrm>
+          <a:prstGeom prst="rect">
+            <a:avLst/>
+          </a:prstGeom>
+          <a:noFill/>
+        </p:spPr>
+        <p:txBody>
+          <a:bodyPr wrap="square" anchor="t">
+            <a:spAutoFit/>
+          </a:bodyPr>
+          <a:lstStyle/>
+          <a:p>
+            <a:pPr algn="l">
+              <a:lnSpc>
+                <a:spcPct val="106000"/>
+              </a:lnSpc>
+              <a:spcBef>
+                <a:spcPts val="0"/>
+              </a:spcBef>
+              <a:spcAft>
+                <a:spcPts val="0"/>
+              </a:spcAft>
+            </a:pPr>
+            <a:r>
+              <a:rPr sz="1100" b="1">
+                <a:solidFill>
+                  <a:srgbClr val="8B919D"/>
+                </a:solidFill>
+                <a:latin typeface="Consolas"/>
+              </a:rPr>
+              <a:t>CROWDED — “CAPTURE”</a:t>
+            </a:r>
+          </a:p>
+        </p:txBody>
+      </p:sp>
+      <p:sp>
+        <p:nvSpPr>
           <p:cNvPr id="8" name="TextBox 7"/>
           <p:cNvSpPr txBox="1"/>
           <p:nvPr/>
         </p:nvSpPr>
         <p:spPr>
           <a:xfrm>
-            <a:off x="822960" y="6419088"/>
-            <a:ext cx="10515600" cy="320040"/>
+            <a:off x="1097280" y="2907792"/>
+            <a:ext cx="4754880" cy="457200"/>
           </a:xfrm>
           <a:prstGeom prst="rect">
             <a:avLst/>
@@ -8631,13 +8296,348 @@
               </a:spcAft>
             </a:pPr>
             <a:r>
-              <a:rPr sz="1050" b="0">
-                <a:solidFill>
-                  <a:srgbClr val="8B919D"/>
+              <a:rPr sz="1900" b="1">
+                <a:solidFill>
+                  <a:srgbClr val="16181F"/>
                 </a:solidFill>
                 <a:latin typeface="Calibri"/>
               </a:rPr>
-              <a:t>Real output from the live app — extracted in ~2.8s: summary, decisions, and one column per owner, each card one click from a prefilled Calendar event or Gmail draft.</a:t>
+              <a:t>Transcribe &amp; summarize</a:t>
+            </a:r>
+          </a:p>
+        </p:txBody>
+      </p:sp>
+      <p:sp>
+        <p:nvSpPr>
+          <p:cNvPr id="9" name="TextBox 8"/>
+          <p:cNvSpPr txBox="1"/>
+          <p:nvPr/>
+        </p:nvSpPr>
+        <p:spPr>
+          <a:xfrm>
+            <a:off x="1097280" y="3429000"/>
+            <a:ext cx="4754880" cy="914400"/>
+          </a:xfrm>
+          <a:prstGeom prst="rect">
+            <a:avLst/>
+          </a:prstGeom>
+          <a:noFill/>
+        </p:spPr>
+        <p:txBody>
+          <a:bodyPr wrap="square" anchor="t">
+            <a:spAutoFit/>
+          </a:bodyPr>
+          <a:lstStyle/>
+          <a:p>
+            <a:pPr algn="l">
+              <a:lnSpc>
+                <a:spcPct val="112000"/>
+              </a:lnSpc>
+              <a:spcBef>
+                <a:spcPts val="0"/>
+              </a:spcBef>
+              <a:spcAft>
+                <a:spcPts val="0"/>
+              </a:spcAft>
+            </a:pPr>
+            <a:r>
+              <a:rPr sz="1350" b="0">
+                <a:solidFill>
+                  <a:srgbClr val="5A616E"/>
+                </a:solidFill>
+                <a:latin typeface="Calibri"/>
+              </a:rPr>
+              <a:t>Otter, Fireflies, Fathom, Granola — all competing on better transcripts. Table stakes now. The commitments they surface still die in a doc.</a:t>
+            </a:r>
+          </a:p>
+        </p:txBody>
+      </p:sp>
+      <p:sp>
+        <p:nvSpPr>
+          <p:cNvPr id="10" name="Rounded Rectangle 9"/>
+          <p:cNvSpPr/>
+          <p:nvPr/>
+        </p:nvSpPr>
+        <p:spPr>
+          <a:xfrm>
+            <a:off x="6263640" y="2286000"/>
+            <a:ext cx="5120640" cy="2148840"/>
+          </a:xfrm>
+          <a:prstGeom prst="roundRect">
+            <a:avLst>
+              <a:gd name="adj" fmla="val 4500"/>
+            </a:avLst>
+          </a:prstGeom>
+          <a:solidFill>
+            <a:srgbClr val="FBEFEA"/>
+          </a:solidFill>
+          <a:ln w="17780">
+            <a:solidFill>
+              <a:srgbClr val="C2410C"/>
+            </a:solidFill>
+          </a:ln>
+          <a:effectLst/>
+        </p:spPr>
+        <p:style>
+          <a:lnRef idx="1">
+            <a:schemeClr val="accent1"/>
+          </a:lnRef>
+          <a:fillRef idx="3">
+            <a:schemeClr val="accent1"/>
+          </a:fillRef>
+          <a:effectRef idx="2">
+            <a:schemeClr val="accent1"/>
+          </a:effectRef>
+          <a:fontRef idx="minor">
+            <a:schemeClr val="lt1"/>
+          </a:fontRef>
+        </p:style>
+        <p:txBody>
+          <a:bodyPr rtlCol="0" anchor="ctr"/>
+          <a:lstStyle/>
+          <a:p>
+            <a:pPr algn="ctr"/>
+          </a:p>
+        </p:txBody>
+      </p:sp>
+      <p:sp>
+        <p:nvSpPr>
+          <p:cNvPr id="11" name="TextBox 10"/>
+          <p:cNvSpPr txBox="1"/>
+          <p:nvPr/>
+        </p:nvSpPr>
+        <p:spPr>
+          <a:xfrm>
+            <a:off x="6537960" y="2487168"/>
+            <a:ext cx="4572000" cy="365760"/>
+          </a:xfrm>
+          <a:prstGeom prst="rect">
+            <a:avLst/>
+          </a:prstGeom>
+          <a:noFill/>
+        </p:spPr>
+        <p:txBody>
+          <a:bodyPr wrap="square" anchor="t">
+            <a:spAutoFit/>
+          </a:bodyPr>
+          <a:lstStyle/>
+          <a:p>
+            <a:pPr algn="l">
+              <a:lnSpc>
+                <a:spcPct val="106000"/>
+              </a:lnSpc>
+              <a:spcBef>
+                <a:spcPts val="0"/>
+              </a:spcBef>
+              <a:spcAft>
+                <a:spcPts val="0"/>
+              </a:spcAft>
+            </a:pPr>
+            <a:r>
+              <a:rPr sz="1100" b="1">
+                <a:solidFill>
+                  <a:srgbClr val="C2410C"/>
+                </a:solidFill>
+                <a:latin typeface="Consolas"/>
+              </a:rPr>
+              <a:t>OPEN — “THE LAST MILE”</a:t>
+            </a:r>
+          </a:p>
+        </p:txBody>
+      </p:sp>
+      <p:sp>
+        <p:nvSpPr>
+          <p:cNvPr id="12" name="TextBox 11"/>
+          <p:cNvSpPr txBox="1"/>
+          <p:nvPr/>
+        </p:nvSpPr>
+        <p:spPr>
+          <a:xfrm>
+            <a:off x="6537960" y="2907792"/>
+            <a:ext cx="4572000" cy="457200"/>
+          </a:xfrm>
+          <a:prstGeom prst="rect">
+            <a:avLst/>
+          </a:prstGeom>
+          <a:noFill/>
+        </p:spPr>
+        <p:txBody>
+          <a:bodyPr wrap="square" anchor="t">
+            <a:spAutoFit/>
+          </a:bodyPr>
+          <a:lstStyle/>
+          <a:p>
+            <a:pPr algn="l">
+              <a:lnSpc>
+                <a:spcPct val="106000"/>
+              </a:lnSpc>
+              <a:spcBef>
+                <a:spcPts val="0"/>
+              </a:spcBef>
+              <a:spcAft>
+                <a:spcPts val="0"/>
+              </a:spcAft>
+            </a:pPr>
+            <a:r>
+              <a:rPr sz="1900" b="1">
+                <a:solidFill>
+                  <a:srgbClr val="16181F"/>
+                </a:solidFill>
+                <a:latin typeface="Calibri"/>
+              </a:rPr>
+              <a:t>Distribute &amp; act</a:t>
+            </a:r>
+          </a:p>
+        </p:txBody>
+      </p:sp>
+      <p:sp>
+        <p:nvSpPr>
+          <p:cNvPr id="13" name="TextBox 12"/>
+          <p:cNvSpPr txBox="1"/>
+          <p:nvPr/>
+        </p:nvSpPr>
+        <p:spPr>
+          <a:xfrm>
+            <a:off x="6537960" y="3429000"/>
+            <a:ext cx="4572000" cy="914400"/>
+          </a:xfrm>
+          <a:prstGeom prst="rect">
+            <a:avLst/>
+          </a:prstGeom>
+          <a:noFill/>
+        </p:spPr>
+        <p:txBody>
+          <a:bodyPr wrap="square" anchor="t">
+            <a:spAutoFit/>
+          </a:bodyPr>
+          <a:lstStyle/>
+          <a:p>
+            <a:pPr algn="l">
+              <a:lnSpc>
+                <a:spcPct val="112000"/>
+              </a:lnSpc>
+              <a:spcBef>
+                <a:spcPts val="0"/>
+              </a:spcBef>
+              <a:spcAft>
+                <a:spcPts val="0"/>
+              </a:spcAft>
+            </a:pPr>
+            <a:r>
+              <a:rPr sz="1350" b="0">
+                <a:solidFill>
+                  <a:srgbClr val="5A616E"/>
+                </a:solidFill>
+                <a:latin typeface="Calibri"/>
+              </a:rPr>
+              <a:t>Getting each commitment into the tool the owner actually lives in — their calendar, their inbox — is where follow-through is won or lost.</a:t>
+            </a:r>
+          </a:p>
+        </p:txBody>
+      </p:sp>
+      <p:sp>
+        <p:nvSpPr>
+          <p:cNvPr id="14" name="Rectangle 13"/>
+          <p:cNvSpPr/>
+          <p:nvPr/>
+        </p:nvSpPr>
+        <p:spPr>
+          <a:xfrm>
+            <a:off x="822960" y="4892040"/>
+            <a:ext cx="54864" cy="1097280"/>
+          </a:xfrm>
+          <a:prstGeom prst="rect">
+            <a:avLst/>
+          </a:prstGeom>
+          <a:solidFill>
+            <a:srgbClr val="C2410C"/>
+          </a:solidFill>
+          <a:ln>
+            <a:noFill/>
+          </a:ln>
+          <a:effectLst/>
+        </p:spPr>
+        <p:style>
+          <a:lnRef idx="1">
+            <a:schemeClr val="accent1"/>
+          </a:lnRef>
+          <a:fillRef idx="3">
+            <a:schemeClr val="accent1"/>
+          </a:fillRef>
+          <a:effectRef idx="2">
+            <a:schemeClr val="accent1"/>
+          </a:effectRef>
+          <a:fontRef idx="minor">
+            <a:schemeClr val="lt1"/>
+          </a:fontRef>
+        </p:style>
+        <p:txBody>
+          <a:bodyPr rtlCol="0" anchor="ctr"/>
+          <a:lstStyle/>
+          <a:p>
+            <a:pPr algn="ctr"/>
+          </a:p>
+        </p:txBody>
+      </p:sp>
+      <p:sp>
+        <p:nvSpPr>
+          <p:cNvPr id="15" name="TextBox 14"/>
+          <p:cNvSpPr txBox="1"/>
+          <p:nvPr/>
+        </p:nvSpPr>
+        <p:spPr>
+          <a:xfrm>
+            <a:off x="1097280" y="4983480"/>
+            <a:ext cx="10241280" cy="1005840"/>
+          </a:xfrm>
+          <a:prstGeom prst="rect">
+            <a:avLst/>
+          </a:prstGeom>
+          <a:noFill/>
+        </p:spPr>
+        <p:txBody>
+          <a:bodyPr wrap="square" anchor="t">
+            <a:spAutoFit/>
+          </a:bodyPr>
+          <a:lstStyle/>
+          <a:p>
+            <a:pPr algn="l">
+              <a:lnSpc>
+                <a:spcPct val="114000"/>
+              </a:lnSpc>
+              <a:spcBef>
+                <a:spcPts val="0"/>
+              </a:spcBef>
+              <a:spcAft>
+                <a:spcPts val="0"/>
+              </a:spcAft>
+            </a:pPr>
+            <a:r>
+              <a:rPr sz="2100" b="0">
+                <a:solidFill>
+                  <a:srgbClr val="16181F"/>
+                </a:solidFill>
+                <a:latin typeface="Calibri"/>
+              </a:rPr>
+              <a:t>The blocker on the last mile isn't a smarter model — it's </a:t>
+            </a:r>
+            <a:r>
+              <a:rPr sz="2100" b="1">
+                <a:solidFill>
+                  <a:srgbClr val="C2410C"/>
+                </a:solidFill>
+                <a:latin typeface="Calibri"/>
+              </a:rPr>
+              <a:t>setup friction</a:t>
+            </a:r>
+            <a:r>
+              <a:rPr sz="2100" b="0">
+                <a:solidFill>
+                  <a:srgbClr val="16181F"/>
+                </a:solidFill>
+                <a:latin typeface="Calibri"/>
+              </a:rPr>
+              <a:t>. So the wedge is zero-setup distribution.</a:t>
             </a:r>
           </a:p>
         </p:txBody>

</xml_diff>

<commit_message>
Highlight the PromptWars award properly (2nd Runner-Up, with proof)
The award was buried as "3rd prize 🥉" in a footer. It's a real, verifiable
credential from a Google for Developers x Hack2Skill event and deserves to be
visible before any claim the deck makes.

- Use the official title: "2nd Runner-Up" (same placing, proper phrasing) and
  name the event/organisers: PromptWars Chennai 2026.
- Link the LinkedIn announcement everywhere as proof — a checkable credential
  beats an asserted one.
- Add an award badge to the pitch deck title slide, the .pptx title slide, and
  the case-study hub header; promote it to the top of the README.
- App footer now links the announcement instead of asserting "3rd prize".

Co-Authored-By: Claude Opus 4.8 (1M context) <noreply@anthropic.com>
</commit_message>
<xml_diff>
--- a/docs/postmeet-pitch.pptx
+++ b/docs/postmeet-pitch.pptx
@@ -3361,7 +3361,7 @@
         </p:nvSpPr>
         <p:spPr>
           <a:xfrm>
-            <a:off x="822960" y="5120640"/>
+            <a:off x="822960" y="5047488"/>
             <a:ext cx="10515600" cy="365760"/>
           </a:xfrm>
           <a:prstGeom prst="rect">
@@ -3409,13 +3409,115 @@
       </p:sp>
       <p:sp>
         <p:nvSpPr>
-          <p:cNvPr id="8" name="TextBox 7"/>
-          <p:cNvSpPr txBox="1"/>
-          <p:nvPr/>
-        </p:nvSpPr>
-        <p:spPr>
-          <a:xfrm>
-            <a:off x="822960" y="5623560"/>
+          <p:cNvPr id="8" name="Rounded Rectangle 7"/>
+          <p:cNvSpPr/>
+          <p:nvPr/>
+        </p:nvSpPr>
+        <p:spPr>
+          <a:xfrm>
+            <a:off x="822960" y="5486400"/>
+            <a:ext cx="5623560" cy="402336"/>
+          </a:xfrm>
+          <a:prstGeom prst="roundRect">
+            <a:avLst>
+              <a:gd name="adj" fmla="val 4500"/>
+            </a:avLst>
+          </a:prstGeom>
+          <a:solidFill>
+            <a:srgbClr val="FBEFEA"/>
+          </a:solidFill>
+          <a:ln w="15240">
+            <a:solidFill>
+              <a:srgbClr val="C2410C"/>
+            </a:solidFill>
+          </a:ln>
+          <a:effectLst/>
+        </p:spPr>
+        <p:style>
+          <a:lnRef idx="1">
+            <a:schemeClr val="accent1"/>
+          </a:lnRef>
+          <a:fillRef idx="3">
+            <a:schemeClr val="accent1"/>
+          </a:fillRef>
+          <a:effectRef idx="2">
+            <a:schemeClr val="accent1"/>
+          </a:effectRef>
+          <a:fontRef idx="minor">
+            <a:schemeClr val="lt1"/>
+          </a:fontRef>
+        </p:style>
+        <p:txBody>
+          <a:bodyPr rtlCol="0" anchor="ctr"/>
+          <a:lstStyle/>
+          <a:p>
+            <a:pPr algn="ctr"/>
+          </a:p>
+        </p:txBody>
+      </p:sp>
+      <p:sp>
+        <p:nvSpPr>
+          <p:cNvPr id="9" name="TextBox 8"/>
+          <p:cNvSpPr txBox="1"/>
+          <p:nvPr/>
+        </p:nvSpPr>
+        <p:spPr>
+          <a:xfrm>
+            <a:off x="1024128" y="5541264"/>
+            <a:ext cx="5394960" cy="310896"/>
+          </a:xfrm>
+          <a:prstGeom prst="rect">
+            <a:avLst/>
+          </a:prstGeom>
+          <a:noFill/>
+        </p:spPr>
+        <p:txBody>
+          <a:bodyPr wrap="square" anchor="t">
+            <a:spAutoFit/>
+          </a:bodyPr>
+          <a:lstStyle/>
+          <a:p>
+            <a:pPr algn="l">
+              <a:lnSpc>
+                <a:spcPct val="106000"/>
+              </a:lnSpc>
+              <a:spcBef>
+                <a:spcPts val="0"/>
+              </a:spcBef>
+              <a:spcAft>
+                <a:spcPts val="0"/>
+              </a:spcAft>
+            </a:pPr>
+            <a:r>
+              <a:rPr sz="1150" b="1">
+                <a:solidFill>
+                  <a:srgbClr val="C2410C"/>
+                </a:solidFill>
+                <a:latin typeface="Consolas"/>
+              </a:rPr>
+              <a:t>🏆  2nd Runner-Up</a:t>
+            </a:r>
+            <a:r>
+              <a:rPr sz="1000" b="0">
+                <a:solidFill>
+                  <a:srgbClr val="5A616E"/>
+                </a:solidFill>
+                <a:latin typeface="Consolas"/>
+              </a:rPr>
+              <a:t>  ·  PromptWars Chennai 2026  ·  Google for Developers × Hack2Skill</a:t>
+            </a:r>
+          </a:p>
+        </p:txBody>
+      </p:sp>
+      <p:sp>
+        <p:nvSpPr>
+          <p:cNvPr id="10" name="TextBox 9"/>
+          <p:cNvSpPr txBox="1"/>
+          <p:nvPr/>
+        </p:nvSpPr>
+        <p:spPr>
+          <a:xfrm>
+            <a:off x="822960" y="6053328"/>
             <a:ext cx="10515600" cy="365760"/>
           </a:xfrm>
           <a:prstGeom prst="rect">

</xml_diff>

<commit_message>
Award: include the Top 10 selection alongside 2nd Runner-Up
Two distinct achievements — selected Top 10, then placed 2nd Runner-Up. The
progression reads stronger than either alone, so state both across every
surface: README, pitch deck, .pptx title slide, case-study hub + docs, and the
live app footer. All still link the LinkedIn announcement as proof.

Co-Authored-By: Claude Opus 4.8 (1M context) <noreply@anthropic.com>
</commit_message>
<xml_diff>
--- a/docs/postmeet-pitch.pptx
+++ b/docs/postmeet-pitch.pptx
@@ -3416,7 +3416,7 @@
         <p:spPr>
           <a:xfrm>
             <a:off x="822960" y="5486400"/>
-            <a:ext cx="5623560" cy="402336"/>
+            <a:ext cx="8138160" cy="402336"/>
           </a:xfrm>
           <a:prstGeom prst="roundRect">
             <a:avLst>
@@ -3464,7 +3464,7 @@
         <p:spPr>
           <a:xfrm>
             <a:off x="1024128" y="5541264"/>
-            <a:ext cx="5394960" cy="310896"/>
+            <a:ext cx="7863840" cy="310896"/>
           </a:xfrm>
           <a:prstGeom prst="rect">
             <a:avLst/>
@@ -3495,7 +3495,7 @@
                 </a:solidFill>
                 <a:latin typeface="Consolas"/>
               </a:rPr>
-              <a:t>🏆  2nd Runner-Up</a:t>
+              <a:t>🏆  Top 10 Finalist → 2nd Runner-Up</a:t>
             </a:r>
             <a:r>
               <a:rPr sz="1000" b="0">

</xml_diff>

<commit_message>
Show the deck in-site: render real .pptx slides to a browsable viewer + PDF
The .pptx was download-only and needed PowerPoint to read. Now the actual
slides render in the same UI as the case study — no download, no Office.

- tools/build_slides.py: .pptx → PDF (LibreOffice) → PNGs (PyMuPDF) → a styled
  viewer at docs/slides/ with lazy-loaded slides, theme toggle and print CSS.
- Also ships docs/postmeet-pitch.pdf — viewable inline and easy to attach.
- The bare "Download .pptx" link is replaced by "View slides"; the .pptx/PDF
  downloads now live on the viewer, so every entry point is readable in-site.

Fixes a real defect caught while rendering: the award badge on the .pptx title
slide overflowed its box (the text wrapped once LibreOffice substituted the
mono font). It's now a two-line badge that fits.

Co-Authored-By: Claude Opus 4.8 (1M context) <noreply@anthropic.com>
</commit_message>
<xml_diff>
--- a/docs/postmeet-pitch.pptx
+++ b/docs/postmeet-pitch.pptx
@@ -3361,7 +3361,7 @@
         </p:nvSpPr>
         <p:spPr>
           <a:xfrm>
-            <a:off x="822960" y="5047488"/>
+            <a:off x="822960" y="4956048"/>
             <a:ext cx="10515600" cy="365760"/>
           </a:xfrm>
           <a:prstGeom prst="rect">
@@ -3415,8 +3415,8 @@
         </p:nvSpPr>
         <p:spPr>
           <a:xfrm>
-            <a:off x="822960" y="5486400"/>
-            <a:ext cx="8138160" cy="402336"/>
+            <a:off x="822960" y="5349240"/>
+            <a:ext cx="5440680" cy="713232"/>
           </a:xfrm>
           <a:prstGeom prst="roundRect">
             <a:avLst>
@@ -3463,8 +3463,8 @@
         </p:nvSpPr>
         <p:spPr>
           <a:xfrm>
-            <a:off x="1024128" y="5541264"/>
-            <a:ext cx="7863840" cy="310896"/>
+            <a:off x="1051560" y="5422392"/>
+            <a:ext cx="5029200" cy="274320"/>
           </a:xfrm>
           <a:prstGeom prst="rect">
             <a:avLst/>
@@ -3497,27 +3497,63 @@
               </a:rPr>
               <a:t>🏆  Top 10 Finalist → 2nd Runner-Up</a:t>
             </a:r>
-            <a:r>
-              <a:rPr sz="1000" b="0">
+          </a:p>
+        </p:txBody>
+      </p:sp>
+      <p:sp>
+        <p:nvSpPr>
+          <p:cNvPr id="10" name="TextBox 9"/>
+          <p:cNvSpPr txBox="1"/>
+          <p:nvPr/>
+        </p:nvSpPr>
+        <p:spPr>
+          <a:xfrm>
+            <a:off x="1051560" y="5705856"/>
+            <a:ext cx="5029200" cy="274320"/>
+          </a:xfrm>
+          <a:prstGeom prst="rect">
+            <a:avLst/>
+          </a:prstGeom>
+          <a:noFill/>
+        </p:spPr>
+        <p:txBody>
+          <a:bodyPr wrap="square" anchor="t">
+            <a:spAutoFit/>
+          </a:bodyPr>
+          <a:lstStyle/>
+          <a:p>
+            <a:pPr algn="l">
+              <a:lnSpc>
+                <a:spcPct val="106000"/>
+              </a:lnSpc>
+              <a:spcBef>
+                <a:spcPts val="0"/>
+              </a:spcBef>
+              <a:spcAft>
+                <a:spcPts val="0"/>
+              </a:spcAft>
+            </a:pPr>
+            <a:r>
+              <a:rPr sz="850" b="0">
                 <a:solidFill>
                   <a:srgbClr val="5A616E"/>
                 </a:solidFill>
                 <a:latin typeface="Consolas"/>
               </a:rPr>
-              <a:t>  ·  PromptWars Chennai 2026  ·  Google for Developers × Hack2Skill</a:t>
-            </a:r>
-          </a:p>
-        </p:txBody>
-      </p:sp>
-      <p:sp>
-        <p:nvSpPr>
-          <p:cNvPr id="10" name="TextBox 9"/>
-          <p:cNvSpPr txBox="1"/>
-          <p:nvPr/>
-        </p:nvSpPr>
-        <p:spPr>
-          <a:xfrm>
-            <a:off x="822960" y="6053328"/>
+              <a:t>PromptWars Chennai 2026 · Google for Developers × Hack2Skill</a:t>
+            </a:r>
+          </a:p>
+        </p:txBody>
+      </p:sp>
+      <p:sp>
+        <p:nvSpPr>
+          <p:cNvPr id="11" name="TextBox 10"/>
+          <p:cNvSpPr txBox="1"/>
+          <p:nvPr/>
+        </p:nvSpPr>
+        <p:spPr>
+          <a:xfrm>
+            <a:off x="822960" y="6199632"/>
             <a:ext cx="10515600" cy="365760"/>
           </a:xfrm>
           <a:prstGeom prst="rect">

</xml_diff>